<commit_message>
v0.24.5: the contact slide signs with the SE who ran the visit
thank_you.pptx's contact block is tokenized at extraction ({{contact_*}},
a fixup that fails loudly if the template's block ever changes shape) and
filled at the lowest point — template_slides.append — from a per-user
profile at ~/.ov-report-generator/engineer.json, so the closing run and
hand-written build scripts both sign correctly without passing anything.

Collected once: /ov-test-report folds name/email/phone into its single
permitted up-front question at the preflight moment, then never asks
again. Every degraded path (direct skill invocation, headless deckgen,
skipped or partial answers, malformed file) renders visibly generic
placeholders — SE Name / SE Email / SE Contact Number — never the wrong
person; deck-plan.json records the contact source and the summary must
relay a placeholder contact. SG_ENGINEER_* env vars override per run.

Co-Authored-By: Claude Fable 5 <noreply@anthropic.com>
</commit_message>
<xml_diff>
--- a/skills/overview-deck/assets/skeletons/thank_you.pptx
+++ b/skills/overview-deck/assets/skeletons/thank_you.pptx
@@ -22725,7 +22725,7 @@
                 <a:cs typeface="Montserrat"/>
                 <a:sym typeface="Montserrat"/>
               </a:rPr>
-              <a:t>aagarwal@overview.ai</a:t>
+              <a:t>{{contact_email}}</a:t>
             </a:r>
             <a:endParaRPr b="0" i="0" sz="1867" u="none" cap="none" strike="noStrike">
               <a:solidFill>
@@ -22765,7 +22765,7 @@
                 <a:cs typeface="Montserrat"/>
                 <a:sym typeface="Montserrat"/>
               </a:rPr>
-              <a:t>(510) 880-1463</a:t>
+              <a:t>{{contact_phone}}</a:t>
             </a:r>
             <a:endParaRPr b="0" i="0" sz="1867" u="none" cap="none" strike="noStrike">
               <a:solidFill>
@@ -22831,7 +22831,7 @@
                 <a:cs typeface="Montserrat SemiBold"/>
                 <a:sym typeface="Montserrat SemiBold"/>
               </a:rPr>
-              <a:t>Akshat Agarwal</a:t>
+              <a:t>{{contact_name}}</a:t>
             </a:r>
             <a:endParaRPr b="0" i="0" sz="3200" u="none" cap="none" strike="noStrike">
               <a:solidFill>

</xml_diff>